<commit_message>
refactor: renomeia chave do H2 de startup para h2-bootstrap e ajusta apresentacao
- DatabaseConfig: BOOTSTRAP_KEY -> H2_BOOTSTRAP_KEY ("h2-bootstrap"), com o
  mesmo nome no pool Hikari; comentario explica que e a chave do mapa de bancos
- README: secao "Por que existe um H2 (h2-bootstrap)?"
- Apresentacao final: slide 4 com o novo nome e texto do item 3 reescrito;
  slide 6 sem o bloco "Header e entrada do cliente", reorganizado em 3 colunas

Co-Authored-By: Claude Opus 5.5 <noreply@anthropic.com>
</commit_message>
<xml_diff>
--- a/docs/lambda-multitenant-workshop-apresentação-final.pptx
+++ b/docs/lambda-multitenant-workshop-apresentação-final.pptx
@@ -5,7 +5,7 @@
     <p:sldMasterId id="2147483648" r:id="rId1"/>
   </p:sldMasterIdLst>
   <p:notesMasterIdLst>
-    <p:notesMasterId r:id="rId9"/>
+    <p:notesMasterId r:id="rId8"/>
   </p:notesMasterIdLst>
   <p:sldIdLst>
     <p:sldId id="256" r:id="rId2"/>
@@ -14,7 +14,6 @@
     <p:sldId id="259" r:id="rId5"/>
     <p:sldId id="260" r:id="rId6"/>
     <p:sldId id="261" r:id="rId7"/>
-    <p:sldId id="262" r:id="rId8"/>
   </p:sldIdLst>
   <p:sldSz cx="12192000" cy="6858000"/>
   <p:notesSz cx="6858000" cy="12192000"/>
@@ -724,7 +723,7 @@
           <a:p>
             <a:r>
               <a:rPr lang="en-US" dirty="0"/>
-              <a:t>Pool: mesmo padrão que adotamos em julho/2026 depois de esgotar conexões do Postgres em DEV (minimumIdle=1 prendia 1 conexão por container). ThreadLocal: bug clássico e silencioso em ambiente com reuso de thread. Segurança: o header é controlado pelo cliente; aqui ele é aceito para fins didáticos, mas em produção o tenant deve ser derivado de uma identidade autenticada.</a:t>
+              <a:t>Pool: mesmo padrão que adotamos em julho/2026 depois de esgotar conexões do Postgres em DEV (minimumIdle=1 prendia 1 conexão por container). ThreadLocal: bug clássico e silencioso em ambiente com reuso de thread.</a:t>
             </a:r>
           </a:p>
         </p:txBody>
@@ -747,93 +746,6 @@
             <a:fld id="{F7021451-1387-4CA6-816F-3879F97B5CBC}" type="slidenum">
               <a:rPr lang="en-US"/>
               <a:t>6</a:t>
-            </a:fld>
-            <a:endParaRPr lang="en-US"/>
-          </a:p>
-        </p:txBody>
-      </p:sp>
-    </p:spTree>
-    <p:extLst>
-      <p:ext uri="{BB962C8B-B14F-4D97-AF65-F5344CB8AC3E}">
-        <p14:creationId xmlns:p14="http://schemas.microsoft.com/office/powerpoint/2010/main" val="1024086991"/>
-      </p:ext>
-    </p:extLst>
-  </p:cSld>
-  <p:clrMapOvr>
-    <a:masterClrMapping/>
-  </p:clrMapOvr>
-</p:notes>
-</file>
-
-<file path=ppt/notesSlides/notesSlide7.xml><?xml version="1.0" encoding="utf-8"?>
-<p:notes xmlns:a="http://schemas.openxmlformats.org/drawingml/2006/main" xmlns:r="http://schemas.openxmlformats.org/officeDocument/2006/relationships" xmlns:p="http://schemas.openxmlformats.org/presentationml/2006/main">
-  <p:cSld>
-    <p:spTree>
-      <p:nvGrpSpPr>
-        <p:cNvPr id="1" name=""/>
-        <p:cNvGrpSpPr/>
-        <p:nvPr/>
-      </p:nvGrpSpPr>
-      <p:grpSpPr>
-        <a:xfrm>
-          <a:off x="0" y="0"/>
-          <a:ext cx="0" cy="0"/>
-          <a:chOff x="0" y="0"/>
-          <a:chExt cx="0" cy="0"/>
-        </a:xfrm>
-      </p:grpSpPr>
-      <p:sp>
-        <p:nvSpPr>
-          <p:cNvPr id="2" name="Slide Image Placeholder 1"/>
-          <p:cNvSpPr>
-            <a:spLocks noGrp="1" noRot="1" noChangeAspect="1"/>
-          </p:cNvSpPr>
-          <p:nvPr>
-            <p:ph type="sldImg"/>
-          </p:nvPr>
-        </p:nvSpPr>
-        <p:spPr/>
-      </p:sp>
-      <p:sp>
-        <p:nvSpPr>
-          <p:cNvPr id="3" name="Notes Placeholder 2"/>
-          <p:cNvSpPr>
-            <a:spLocks noGrp="1"/>
-          </p:cNvSpPr>
-          <p:nvPr>
-            <p:ph type="body" idx="1"/>
-          </p:nvPr>
-        </p:nvSpPr>
-        <p:spPr/>
-        <p:txBody>
-          <a:bodyPr/>
-          <a:lstStyle/>
-          <a:p>
-            <a:r>
-              <a:rPr lang="en-US" dirty="0"/>
-              <a:t>Fechar com a evolução natural. No agilcorp o tenant do JWT já existe em parte (claim contaAtivaId). Abrir para perguntas.</a:t>
-            </a:r>
-          </a:p>
-        </p:txBody>
-      </p:sp>
-      <p:sp>
-        <p:nvSpPr>
-          <p:cNvPr id="4" name="Slide Number Placeholder 3"/>
-          <p:cNvSpPr>
-            <a:spLocks noGrp="1"/>
-          </p:cNvSpPr>
-          <p:nvPr>
-            <p:ph type="sldNum" sz="quarter" idx="10"/>
-          </p:nvPr>
-        </p:nvSpPr>
-        <p:spPr/>
-        <p:txBody>
-          <a:bodyPr/>
-          <a:lstStyle/>
-          <a:p>
-            <a:fld id="{F7021451-1387-4CA6-816F-3879F97B5CBC}" type="slidenum">
-              <a:rPr lang="en-US"/>
-              <a:t>7</a:t>
             </a:fld>
             <a:endParaRPr lang="en-US"/>
           </a:p>
@@ -4519,7 +4431,7 @@
                 <a:ea typeface="Courier New" pitchFamily="34" charset="-122"/>
                 <a:cs typeface="Courier New" pitchFamily="34" charset="-120"/>
               </a:rPr>
-              <a:t>        return BOOTSTRAP_KEY;  // só no startup</a:t>
+              <a:t>        return H2_BOOTSTRAP_KEY; // só no startup</a:t>
             </a:r>
             <a:endParaRPr lang="en-US" sz="1500" dirty="0"/>
           </a:p>
@@ -4997,7 +4909,7 @@
                 <a:ea typeface="Arial" pitchFamily="34" charset="-122"/>
                 <a:cs typeface="Arial" pitchFamily="34" charset="-120"/>
               </a:rPr>
-              <a:t>Controller limpo</a:t>
+              <a:t>Controller não muda</a:t>
             </a:r>
             <a:endParaRPr lang="en-US" sz="1700" dirty="0"/>
           </a:p>
@@ -5012,7 +4924,7 @@
         <p:spPr>
           <a:xfrm>
             <a:off x="8686800" y="4983480"/>
-            <a:ext cx="3017520" cy="822960"/>
+            <a:ext cx="3017520" cy="1143000"/>
           </a:xfrm>
           <a:prstGeom prst="rect">
             <a:avLst/>
@@ -5036,7 +4948,7 @@
                 <a:ea typeface="Arial" pitchFamily="34" charset="-122"/>
                 <a:cs typeface="Arial" pitchFamily="34" charset="-120"/>
               </a:rPr>
-              <a:t>UsuarioController é um CRUD comum: zero linha sobre tenant.</a:t>
+              <a:t>O UsuarioController é um CRUD comum: não lê header nem escolhe banco. Quando ele roda, o filtro já definiu o tenant.</a:t>
             </a:r>
             <a:endParaRPr lang="en-US" sz="1300" dirty="0"/>
           </a:p>
@@ -7050,7 +6962,7 @@
         <p:spPr>
           <a:xfrm>
             <a:off x="548640" y="1508760"/>
-            <a:ext cx="5440680" cy="2194560"/>
+            <a:ext cx="3545840" cy="3200400"/>
           </a:xfrm>
           <a:prstGeom prst="roundRect">
             <a:avLst>
@@ -7144,8 +7056,8 @@
         </p:nvSpPr>
         <p:spPr>
           <a:xfrm>
-            <a:off x="1600200" y="1892808"/>
-            <a:ext cx="4206240" cy="457200"/>
+            <a:off x="868680" y="2560320"/>
+            <a:ext cx="2905760" cy="731520"/>
           </a:xfrm>
           <a:prstGeom prst="rect">
             <a:avLst/>
@@ -7183,8 +7095,8 @@
         </p:nvSpPr>
         <p:spPr>
           <a:xfrm>
-            <a:off x="1600200" y="2423160"/>
-            <a:ext cx="4206240" cy="1097280"/>
+            <a:off x="868680" y="3383280"/>
+            <a:ext cx="2905760" cy="1143000"/>
           </a:xfrm>
           <a:prstGeom prst="rect">
             <a:avLst/>
@@ -7239,8 +7151,8 @@
         </p:nvSpPr>
         <p:spPr>
           <a:xfrm>
-            <a:off x="6172200" y="1508760"/>
-            <a:ext cx="5440680" cy="2194560"/>
+            <a:off x="4323080" y="1508760"/>
+            <a:ext cx="3545840" cy="3200400"/>
           </a:xfrm>
           <a:prstGeom prst="roundRect">
             <a:avLst>
@@ -7268,7 +7180,7 @@
         </p:nvSpPr>
         <p:spPr>
           <a:xfrm>
-            <a:off x="6492240" y="1828800"/>
+            <a:off x="4643120" y="1828800"/>
             <a:ext cx="548640" cy="548640"/>
           </a:xfrm>
           <a:prstGeom prst="ellipse">
@@ -7295,7 +7207,7 @@
         </p:nvSpPr>
         <p:spPr>
           <a:xfrm>
-            <a:off x="6492240" y="1828800"/>
+            <a:off x="4643120" y="1828800"/>
             <a:ext cx="548640" cy="548640"/>
           </a:xfrm>
           <a:prstGeom prst="rect">
@@ -7334,8 +7246,8 @@
         </p:nvSpPr>
         <p:spPr>
           <a:xfrm>
-            <a:off x="7223760" y="1892808"/>
-            <a:ext cx="4206240" cy="457200"/>
+            <a:off x="4643120" y="2560320"/>
+            <a:ext cx="2905760" cy="731520"/>
           </a:xfrm>
           <a:prstGeom prst="rect">
             <a:avLst/>
@@ -7373,8 +7285,8 @@
         </p:nvSpPr>
         <p:spPr>
           <a:xfrm>
-            <a:off x="7223760" y="2423160"/>
-            <a:ext cx="4206240" cy="1097280"/>
+            <a:off x="4643120" y="3383280"/>
+            <a:ext cx="2905760" cy="1143000"/>
           </a:xfrm>
           <a:prstGeom prst="rect">
             <a:avLst/>
@@ -7429,8 +7341,8 @@
         </p:nvSpPr>
         <p:spPr>
           <a:xfrm>
-            <a:off x="548640" y="3931920"/>
-            <a:ext cx="5440680" cy="2194560"/>
+            <a:off x="8097520" y="1508760"/>
+            <a:ext cx="3545840" cy="3200400"/>
           </a:xfrm>
           <a:prstGeom prst="roundRect">
             <a:avLst>
@@ -7458,7 +7370,7 @@
         </p:nvSpPr>
         <p:spPr>
           <a:xfrm>
-            <a:off x="868680" y="4251960"/>
+            <a:off x="8417560" y="1828800"/>
             <a:ext cx="548640" cy="548640"/>
           </a:xfrm>
           <a:prstGeom prst="ellipse">
@@ -7485,7 +7397,7 @@
         </p:nvSpPr>
         <p:spPr>
           <a:xfrm>
-            <a:off x="868680" y="4251960"/>
+            <a:off x="8417560" y="1828800"/>
             <a:ext cx="548640" cy="548640"/>
           </a:xfrm>
           <a:prstGeom prst="rect">
@@ -7524,8 +7436,8 @@
         </p:nvSpPr>
         <p:spPr>
           <a:xfrm>
-            <a:off x="1600200" y="4315968"/>
-            <a:ext cx="4206240" cy="457200"/>
+            <a:off x="8417560" y="2560320"/>
+            <a:ext cx="2905760" cy="731520"/>
           </a:xfrm>
           <a:prstGeom prst="rect">
             <a:avLst/>
@@ -7563,8 +7475,8 @@
         </p:nvSpPr>
         <p:spPr>
           <a:xfrm>
-            <a:off x="1600200" y="4846320"/>
-            <a:ext cx="4206240" cy="1097280"/>
+            <a:off x="8417560" y="3383280"/>
+            <a:ext cx="2905760" cy="1143000"/>
           </a:xfrm>
           <a:prstGeom prst="rect">
             <a:avLst/>
@@ -7608,886 +7520,6 @@
               <a:t>Depois disso, só cache.</a:t>
             </a:r>
             <a:endParaRPr lang="en-US" sz="1400" dirty="0"/>
-          </a:p>
-        </p:txBody>
-      </p:sp>
-      <p:sp>
-        <p:nvSpPr>
-          <p:cNvPr id="19" name="Shape 17"/>
-          <p:cNvSpPr/>
-          <p:nvPr/>
-        </p:nvSpPr>
-        <p:spPr>
-          <a:xfrm>
-            <a:off x="6172200" y="3931920"/>
-            <a:ext cx="5440680" cy="2194560"/>
-          </a:xfrm>
-          <a:prstGeom prst="roundRect">
-            <a:avLst>
-              <a:gd name="adj" fmla="val 5000"/>
-            </a:avLst>
-          </a:prstGeom>
-          <a:solidFill>
-            <a:srgbClr val="F2F4F8"/>
-          </a:solidFill>
-          <a:ln/>
-        </p:spPr>
-        <p:txBody>
-          <a:bodyPr/>
-          <a:lstStyle/>
-          <a:p>
-            <a:endParaRPr lang="pt-BR"/>
-          </a:p>
-        </p:txBody>
-      </p:sp>
-      <p:sp>
-        <p:nvSpPr>
-          <p:cNvPr id="20" name="Shape 18"/>
-          <p:cNvSpPr/>
-          <p:nvPr/>
-        </p:nvSpPr>
-        <p:spPr>
-          <a:xfrm>
-            <a:off x="6492240" y="4251960"/>
-            <a:ext cx="548640" cy="548640"/>
-          </a:xfrm>
-          <a:prstGeom prst="ellipse">
-            <a:avLst/>
-          </a:prstGeom>
-          <a:solidFill>
-            <a:srgbClr val="E11D48"/>
-          </a:solidFill>
-          <a:ln/>
-        </p:spPr>
-        <p:txBody>
-          <a:bodyPr/>
-          <a:lstStyle/>
-          <a:p>
-            <a:endParaRPr lang="pt-BR"/>
-          </a:p>
-        </p:txBody>
-      </p:sp>
-      <p:sp>
-        <p:nvSpPr>
-          <p:cNvPr id="21" name="Text 19"/>
-          <p:cNvSpPr txBox="1"/>
-          <p:nvPr/>
-        </p:nvSpPr>
-        <p:spPr>
-          <a:xfrm>
-            <a:off x="6492240" y="4251960"/>
-            <a:ext cx="548640" cy="548640"/>
-          </a:xfrm>
-          <a:prstGeom prst="rect">
-            <a:avLst/>
-          </a:prstGeom>
-          <a:noFill/>
-          <a:ln/>
-        </p:spPr>
-        <p:txBody>
-          <a:bodyPr wrap="square" lIns="0" tIns="0" rIns="0" bIns="0" rtlCol="0" anchor="ctr"/>
-          <a:lstStyle/>
-          <a:p>
-            <a:pPr marL="0" indent="0" algn="ctr">
-              <a:buNone/>
-            </a:pPr>
-            <a:r>
-              <a:rPr lang="en-US" sz="2000" b="1" dirty="0">
-                <a:solidFill>
-                  <a:srgbClr val="FFFFFF"/>
-                </a:solidFill>
-                <a:latin typeface="Arial" pitchFamily="34" charset="0"/>
-                <a:ea typeface="Arial" pitchFamily="34" charset="-122"/>
-                <a:cs typeface="Arial" pitchFamily="34" charset="-120"/>
-              </a:rPr>
-              <a:t>!</a:t>
-            </a:r>
-            <a:endParaRPr lang="en-US" sz="2000" dirty="0"/>
-          </a:p>
-        </p:txBody>
-      </p:sp>
-      <p:sp>
-        <p:nvSpPr>
-          <p:cNvPr id="22" name="Text 20"/>
-          <p:cNvSpPr txBox="1"/>
-          <p:nvPr/>
-        </p:nvSpPr>
-        <p:spPr>
-          <a:xfrm>
-            <a:off x="7223760" y="4315968"/>
-            <a:ext cx="4206240" cy="457200"/>
-          </a:xfrm>
-          <a:prstGeom prst="rect">
-            <a:avLst/>
-          </a:prstGeom>
-          <a:noFill/>
-          <a:ln/>
-        </p:spPr>
-        <p:txBody>
-          <a:bodyPr wrap="square" lIns="0" tIns="0" rIns="0" bIns="0" rtlCol="0" anchor="t"/>
-          <a:lstStyle/>
-          <a:p>
-            <a:pPr marL="0" indent="0" algn="l">
-              <a:buNone/>
-            </a:pPr>
-            <a:r>
-              <a:rPr lang="en-US" sz="1800" b="1" dirty="0">
-                <a:solidFill>
-                  <a:srgbClr val="1B2130"/>
-                </a:solidFill>
-                <a:latin typeface="Arial" pitchFamily="34" charset="0"/>
-                <a:ea typeface="Arial" pitchFamily="34" charset="-122"/>
-                <a:cs typeface="Arial" pitchFamily="34" charset="-120"/>
-              </a:rPr>
-              <a:t>Header é entrada do cliente</a:t>
-            </a:r>
-            <a:endParaRPr lang="en-US" sz="1800" dirty="0"/>
-          </a:p>
-        </p:txBody>
-      </p:sp>
-      <p:sp>
-        <p:nvSpPr>
-          <p:cNvPr id="23" name="Text 21"/>
-          <p:cNvSpPr txBox="1"/>
-          <p:nvPr/>
-        </p:nvSpPr>
-        <p:spPr>
-          <a:xfrm>
-            <a:off x="7223760" y="4846320"/>
-            <a:ext cx="4206240" cy="1097280"/>
-          </a:xfrm>
-          <a:prstGeom prst="rect">
-            <a:avLst/>
-          </a:prstGeom>
-          <a:noFill/>
-          <a:ln/>
-        </p:spPr>
-        <p:txBody>
-          <a:bodyPr wrap="square" lIns="0" tIns="0" rIns="0" bIns="0" rtlCol="0" anchor="t"/>
-          <a:lstStyle/>
-          <a:p>
-            <a:pPr marL="0" indent="0" algn="l">
-              <a:buNone/>
-            </a:pPr>
-            <a:r>
-              <a:rPr lang="en-US" sz="1400" dirty="0">
-                <a:solidFill>
-                  <a:srgbClr val="5B6475"/>
-                </a:solidFill>
-                <a:latin typeface="Arial" pitchFamily="34" charset="0"/>
-                <a:ea typeface="Arial" pitchFamily="34" charset="-122"/>
-                <a:cs typeface="Arial" pitchFamily="34" charset="-120"/>
-              </a:rPr>
-              <a:t>Nada de fallback silencioso para outro banco.</a:t>
-            </a:r>
-            <a:endParaRPr lang="en-US" sz="1400" dirty="0"/>
-          </a:p>
-          <a:p>
-            <a:pPr marL="0" indent="0" algn="l">
-              <a:buNone/>
-            </a:pPr>
-            <a:r>
-              <a:rPr lang="en-US" sz="1400" dirty="0">
-                <a:solidFill>
-                  <a:srgbClr val="5B6475"/>
-                </a:solidFill>
-                <a:latin typeface="Arial" pitchFamily="34" charset="0"/>
-                <a:ea typeface="Arial" pitchFamily="34" charset="-122"/>
-                <a:cs typeface="Arial" pitchFamily="34" charset="-120"/>
-              </a:rPr>
-              <a:t>Em produção: tenant vindo do JWT + allowlist na IAM.</a:t>
-            </a:r>
-            <a:endParaRPr lang="en-US" sz="1400" dirty="0"/>
-          </a:p>
-        </p:txBody>
-      </p:sp>
-    </p:spTree>
-  </p:cSld>
-  <p:clrMapOvr>
-    <a:masterClrMapping/>
-  </p:clrMapOvr>
-</p:sld>
-</file>
-
-<file path=ppt/slides/slide7.xml><?xml version="1.0" encoding="utf-8"?>
-<p:sld xmlns:a="http://schemas.openxmlformats.org/drawingml/2006/main" xmlns:r="http://schemas.openxmlformats.org/officeDocument/2006/relationships" xmlns:p="http://schemas.openxmlformats.org/presentationml/2006/main">
-  <p:cSld name="Slide 7">
-    <p:bg>
-      <p:bgPr>
-        <a:solidFill>
-          <a:srgbClr val="141A26"/>
-        </a:solidFill>
-        <a:effectLst/>
-      </p:bgPr>
-    </p:bg>
-    <p:spTree>
-      <p:nvGrpSpPr>
-        <p:cNvPr id="1" name=""/>
-        <p:cNvGrpSpPr/>
-        <p:nvPr/>
-      </p:nvGrpSpPr>
-      <p:grpSpPr>
-        <a:xfrm>
-          <a:off x="0" y="0"/>
-          <a:ext cx="0" cy="0"/>
-          <a:chOff x="0" y="0"/>
-          <a:chExt cx="0" cy="0"/>
-        </a:xfrm>
-      </p:grpSpPr>
-      <p:sp>
-        <p:nvSpPr>
-          <p:cNvPr id="2" name="Text 0"/>
-          <p:cNvSpPr txBox="1"/>
-          <p:nvPr/>
-        </p:nvSpPr>
-        <p:spPr>
-          <a:xfrm>
-            <a:off x="548640" y="137160"/>
-            <a:ext cx="7315200" cy="320040"/>
-          </a:xfrm>
-          <a:prstGeom prst="rect">
-            <a:avLst/>
-          </a:prstGeom>
-          <a:noFill/>
-          <a:ln/>
-        </p:spPr>
-        <p:txBody>
-          <a:bodyPr wrap="square" lIns="0" tIns="0" rIns="0" bIns="0" rtlCol="0" anchor="ctr"/>
-          <a:lstStyle/>
-          <a:p>
-            <a:pPr marL="0" indent="0">
-              <a:buNone/>
-            </a:pPr>
-            <a:r>
-              <a:rPr lang="en-US" sz="1200" b="1" kern="0" spc="200" dirty="0">
-                <a:solidFill>
-                  <a:srgbClr val="F59E0B"/>
-                </a:solidFill>
-                <a:latin typeface="Arial" pitchFamily="34" charset="0"/>
-                <a:ea typeface="Arial" pitchFamily="34" charset="-122"/>
-                <a:cs typeface="Arial" pitchFamily="34" charset="-120"/>
-              </a:rPr>
-              <a:t>PRÓXIMOS PASSOS</a:t>
-            </a:r>
-            <a:endParaRPr lang="en-US" sz="1200" dirty="0"/>
-          </a:p>
-        </p:txBody>
-      </p:sp>
-      <p:sp>
-        <p:nvSpPr>
-          <p:cNvPr id="3" name="Text 1"/>
-          <p:cNvSpPr txBox="1"/>
-          <p:nvPr/>
-        </p:nvSpPr>
-        <p:spPr>
-          <a:xfrm>
-            <a:off x="548640" y="411480"/>
-            <a:ext cx="11064240" cy="822960"/>
-          </a:xfrm>
-          <a:prstGeom prst="rect">
-            <a:avLst/>
-          </a:prstGeom>
-          <a:noFill/>
-          <a:ln/>
-        </p:spPr>
-        <p:txBody>
-          <a:bodyPr wrap="square" lIns="0" tIns="0" rIns="0" bIns="0" rtlCol="0" anchor="ctr"/>
-          <a:lstStyle/>
-          <a:p>
-            <a:pPr marL="0" indent="0">
-              <a:buNone/>
-            </a:pPr>
-            <a:r>
-              <a:rPr lang="en-US" sz="3400" b="1" dirty="0">
-                <a:solidFill>
-                  <a:srgbClr val="FFFFFF"/>
-                </a:solidFill>
-                <a:latin typeface="Arial" pitchFamily="34" charset="0"/>
-                <a:ea typeface="Arial" pitchFamily="34" charset="-122"/>
-                <a:cs typeface="Arial" pitchFamily="34" charset="-120"/>
-              </a:rPr>
-              <a:t>Para levar isso a produção</a:t>
-            </a:r>
-            <a:endParaRPr lang="en-US" sz="3400" dirty="0"/>
-          </a:p>
-        </p:txBody>
-      </p:sp>
-      <p:sp>
-        <p:nvSpPr>
-          <p:cNvPr id="4" name="Shape 2"/>
-          <p:cNvSpPr/>
-          <p:nvPr/>
-        </p:nvSpPr>
-        <p:spPr>
-          <a:xfrm>
-            <a:off x="548640" y="1691640"/>
-            <a:ext cx="640080" cy="640080"/>
-          </a:xfrm>
-          <a:prstGeom prst="ellipse">
-            <a:avLst/>
-          </a:prstGeom>
-          <a:solidFill>
-            <a:srgbClr val="0EA5A4"/>
-          </a:solidFill>
-          <a:ln/>
-        </p:spPr>
-        <p:txBody>
-          <a:bodyPr/>
-          <a:lstStyle/>
-          <a:p>
-            <a:endParaRPr lang="pt-BR"/>
-          </a:p>
-        </p:txBody>
-      </p:sp>
-      <p:sp>
-        <p:nvSpPr>
-          <p:cNvPr id="5" name="Text 3"/>
-          <p:cNvSpPr txBox="1"/>
-          <p:nvPr/>
-        </p:nvSpPr>
-        <p:spPr>
-          <a:xfrm>
-            <a:off x="548640" y="1691640"/>
-            <a:ext cx="640080" cy="640080"/>
-          </a:xfrm>
-          <a:prstGeom prst="rect">
-            <a:avLst/>
-          </a:prstGeom>
-          <a:noFill/>
-          <a:ln/>
-        </p:spPr>
-        <p:txBody>
-          <a:bodyPr wrap="square" lIns="0" tIns="0" rIns="0" bIns="0" rtlCol="0" anchor="ctr"/>
-          <a:lstStyle/>
-          <a:p>
-            <a:pPr marL="0" indent="0" algn="ctr">
-              <a:buNone/>
-            </a:pPr>
-            <a:r>
-              <a:rPr lang="en-US" sz="2000" b="1" dirty="0">
-                <a:solidFill>
-                  <a:srgbClr val="FFFFFF"/>
-                </a:solidFill>
-                <a:latin typeface="Arial" pitchFamily="34" charset="0"/>
-                <a:ea typeface="Arial" pitchFamily="34" charset="-122"/>
-                <a:cs typeface="Arial" pitchFamily="34" charset="-120"/>
-              </a:rPr>
-              <a:t>1</a:t>
-            </a:r>
-            <a:endParaRPr lang="en-US" sz="2000" dirty="0"/>
-          </a:p>
-        </p:txBody>
-      </p:sp>
-      <p:sp>
-        <p:nvSpPr>
-          <p:cNvPr id="6" name="Text 4"/>
-          <p:cNvSpPr txBox="1"/>
-          <p:nvPr/>
-        </p:nvSpPr>
-        <p:spPr>
-          <a:xfrm>
-            <a:off x="1463040" y="1673352"/>
-            <a:ext cx="5943600" cy="411480"/>
-          </a:xfrm>
-          <a:prstGeom prst="rect">
-            <a:avLst/>
-          </a:prstGeom>
-          <a:noFill/>
-          <a:ln/>
-        </p:spPr>
-        <p:txBody>
-          <a:bodyPr wrap="square" lIns="0" tIns="0" rIns="0" bIns="0" rtlCol="0" anchor="t"/>
-          <a:lstStyle/>
-          <a:p>
-            <a:pPr marL="0" indent="0" algn="l">
-              <a:buNone/>
-            </a:pPr>
-            <a:r>
-              <a:rPr lang="en-US" sz="2000" b="1" dirty="0">
-                <a:solidFill>
-                  <a:srgbClr val="FFFFFF"/>
-                </a:solidFill>
-                <a:latin typeface="Arial" pitchFamily="34" charset="0"/>
-                <a:ea typeface="Arial" pitchFamily="34" charset="-122"/>
-                <a:cs typeface="Arial" pitchFamily="34" charset="-120"/>
-              </a:rPr>
-              <a:t>RDS Proxy</a:t>
-            </a:r>
-            <a:endParaRPr lang="en-US" sz="2000" dirty="0"/>
-          </a:p>
-        </p:txBody>
-      </p:sp>
-      <p:sp>
-        <p:nvSpPr>
-          <p:cNvPr id="7" name="Text 5"/>
-          <p:cNvSpPr txBox="1"/>
-          <p:nvPr/>
-        </p:nvSpPr>
-        <p:spPr>
-          <a:xfrm>
-            <a:off x="1463040" y="2075688"/>
-            <a:ext cx="6217920" cy="457200"/>
-          </a:xfrm>
-          <a:prstGeom prst="rect">
-            <a:avLst/>
-          </a:prstGeom>
-          <a:noFill/>
-          <a:ln/>
-        </p:spPr>
-        <p:txBody>
-          <a:bodyPr wrap="square" lIns="0" tIns="0" rIns="0" bIns="0" rtlCol="0" anchor="t"/>
-          <a:lstStyle/>
-          <a:p>
-            <a:pPr marL="0" indent="0" algn="l">
-              <a:buNone/>
-            </a:pPr>
-            <a:r>
-              <a:rPr lang="en-US" sz="1400" dirty="0">
-                <a:solidFill>
-                  <a:srgbClr val="C9D1E0"/>
-                </a:solidFill>
-                <a:latin typeface="Arial" pitchFamily="34" charset="0"/>
-                <a:ea typeface="Arial" pitchFamily="34" charset="-122"/>
-                <a:cs typeface="Arial" pitchFamily="34" charset="-120"/>
-              </a:rPr>
-              <a:t>na frente do Postgres para absorver o fan-out de conexões.</a:t>
-            </a:r>
-            <a:endParaRPr lang="en-US" sz="1400" dirty="0"/>
-          </a:p>
-        </p:txBody>
-      </p:sp>
-      <p:sp>
-        <p:nvSpPr>
-          <p:cNvPr id="8" name="Shape 6"/>
-          <p:cNvSpPr/>
-          <p:nvPr/>
-        </p:nvSpPr>
-        <p:spPr>
-          <a:xfrm>
-            <a:off x="548640" y="2880360"/>
-            <a:ext cx="640080" cy="640080"/>
-          </a:xfrm>
-          <a:prstGeom prst="ellipse">
-            <a:avLst/>
-          </a:prstGeom>
-          <a:solidFill>
-            <a:srgbClr val="7C3AED"/>
-          </a:solidFill>
-          <a:ln/>
-        </p:spPr>
-        <p:txBody>
-          <a:bodyPr/>
-          <a:lstStyle/>
-          <a:p>
-            <a:endParaRPr lang="pt-BR"/>
-          </a:p>
-        </p:txBody>
-      </p:sp>
-      <p:sp>
-        <p:nvSpPr>
-          <p:cNvPr id="9" name="Text 7"/>
-          <p:cNvSpPr txBox="1"/>
-          <p:nvPr/>
-        </p:nvSpPr>
-        <p:spPr>
-          <a:xfrm>
-            <a:off x="548640" y="2880360"/>
-            <a:ext cx="640080" cy="640080"/>
-          </a:xfrm>
-          <a:prstGeom prst="rect">
-            <a:avLst/>
-          </a:prstGeom>
-          <a:noFill/>
-          <a:ln/>
-        </p:spPr>
-        <p:txBody>
-          <a:bodyPr wrap="square" lIns="0" tIns="0" rIns="0" bIns="0" rtlCol="0" anchor="ctr"/>
-          <a:lstStyle/>
-          <a:p>
-            <a:pPr marL="0" indent="0" algn="ctr">
-              <a:buNone/>
-            </a:pPr>
-            <a:r>
-              <a:rPr lang="en-US" sz="2000" b="1" dirty="0">
-                <a:solidFill>
-                  <a:srgbClr val="FFFFFF"/>
-                </a:solidFill>
-                <a:latin typeface="Arial" pitchFamily="34" charset="0"/>
-                <a:ea typeface="Arial" pitchFamily="34" charset="-122"/>
-                <a:cs typeface="Arial" pitchFamily="34" charset="-120"/>
-              </a:rPr>
-              <a:t>2</a:t>
-            </a:r>
-            <a:endParaRPr lang="en-US" sz="2000" dirty="0"/>
-          </a:p>
-        </p:txBody>
-      </p:sp>
-      <p:sp>
-        <p:nvSpPr>
-          <p:cNvPr id="10" name="Text 8"/>
-          <p:cNvSpPr txBox="1"/>
-          <p:nvPr/>
-        </p:nvSpPr>
-        <p:spPr>
-          <a:xfrm>
-            <a:off x="1463040" y="2862072"/>
-            <a:ext cx="5943600" cy="411480"/>
-          </a:xfrm>
-          <a:prstGeom prst="rect">
-            <a:avLst/>
-          </a:prstGeom>
-          <a:noFill/>
-          <a:ln/>
-        </p:spPr>
-        <p:txBody>
-          <a:bodyPr wrap="square" lIns="0" tIns="0" rIns="0" bIns="0" rtlCol="0" anchor="t"/>
-          <a:lstStyle/>
-          <a:p>
-            <a:pPr marL="0" indent="0" algn="l">
-              <a:buNone/>
-            </a:pPr>
-            <a:r>
-              <a:rPr lang="en-US" sz="2000" b="1" dirty="0">
-                <a:solidFill>
-                  <a:srgbClr val="FFFFFF"/>
-                </a:solidFill>
-                <a:latin typeface="Arial" pitchFamily="34" charset="0"/>
-                <a:ea typeface="Arial" pitchFamily="34" charset="-122"/>
-                <a:cs typeface="Arial" pitchFamily="34" charset="-120"/>
-              </a:rPr>
-              <a:t>Tenant do JWT</a:t>
-            </a:r>
-            <a:endParaRPr lang="en-US" sz="2000" dirty="0"/>
-          </a:p>
-        </p:txBody>
-      </p:sp>
-      <p:sp>
-        <p:nvSpPr>
-          <p:cNvPr id="11" name="Text 9"/>
-          <p:cNvSpPr txBox="1"/>
-          <p:nvPr/>
-        </p:nvSpPr>
-        <p:spPr>
-          <a:xfrm>
-            <a:off x="1463040" y="3264408"/>
-            <a:ext cx="6217920" cy="457200"/>
-          </a:xfrm>
-          <a:prstGeom prst="rect">
-            <a:avLst/>
-          </a:prstGeom>
-          <a:noFill/>
-          <a:ln/>
-        </p:spPr>
-        <p:txBody>
-          <a:bodyPr wrap="square" lIns="0" tIns="0" rIns="0" bIns="0" rtlCol="0" anchor="t"/>
-          <a:lstStyle/>
-          <a:p>
-            <a:pPr marL="0" indent="0" algn="l">
-              <a:buNone/>
-            </a:pPr>
-            <a:r>
-              <a:rPr lang="en-US" sz="1400" dirty="0">
-                <a:solidFill>
-                  <a:srgbClr val="C9D1E0"/>
-                </a:solidFill>
-                <a:latin typeface="Arial" pitchFamily="34" charset="0"/>
-                <a:ea typeface="Arial" pitchFamily="34" charset="-122"/>
-                <a:cs typeface="Arial" pitchFamily="34" charset="-120"/>
-              </a:rPr>
-              <a:t>em vez de header livre — o token diz qual conta a sessão representa.</a:t>
-            </a:r>
-            <a:endParaRPr lang="en-US" sz="1400" dirty="0"/>
-          </a:p>
-        </p:txBody>
-      </p:sp>
-      <p:sp>
-        <p:nvSpPr>
-          <p:cNvPr id="12" name="Shape 10"/>
-          <p:cNvSpPr/>
-          <p:nvPr/>
-        </p:nvSpPr>
-        <p:spPr>
-          <a:xfrm>
-            <a:off x="548640" y="4069080"/>
-            <a:ext cx="640080" cy="640080"/>
-          </a:xfrm>
-          <a:prstGeom prst="ellipse">
-            <a:avLst/>
-          </a:prstGeom>
-          <a:solidFill>
-            <a:srgbClr val="E11D48"/>
-          </a:solidFill>
-          <a:ln/>
-        </p:spPr>
-        <p:txBody>
-          <a:bodyPr/>
-          <a:lstStyle/>
-          <a:p>
-            <a:endParaRPr lang="pt-BR"/>
-          </a:p>
-        </p:txBody>
-      </p:sp>
-      <p:sp>
-        <p:nvSpPr>
-          <p:cNvPr id="13" name="Text 11"/>
-          <p:cNvSpPr txBox="1"/>
-          <p:nvPr/>
-        </p:nvSpPr>
-        <p:spPr>
-          <a:xfrm>
-            <a:off x="548640" y="4069080"/>
-            <a:ext cx="640080" cy="640080"/>
-          </a:xfrm>
-          <a:prstGeom prst="rect">
-            <a:avLst/>
-          </a:prstGeom>
-          <a:noFill/>
-          <a:ln/>
-        </p:spPr>
-        <p:txBody>
-          <a:bodyPr wrap="square" lIns="0" tIns="0" rIns="0" bIns="0" rtlCol="0" anchor="ctr"/>
-          <a:lstStyle/>
-          <a:p>
-            <a:pPr marL="0" indent="0" algn="ctr">
-              <a:buNone/>
-            </a:pPr>
-            <a:r>
-              <a:rPr lang="en-US" sz="2000" b="1" dirty="0">
-                <a:solidFill>
-                  <a:srgbClr val="FFFFFF"/>
-                </a:solidFill>
-                <a:latin typeface="Arial" pitchFamily="34" charset="0"/>
-                <a:ea typeface="Arial" pitchFamily="34" charset="-122"/>
-                <a:cs typeface="Arial" pitchFamily="34" charset="-120"/>
-              </a:rPr>
-              <a:t>3</a:t>
-            </a:r>
-            <a:endParaRPr lang="en-US" sz="2000" dirty="0"/>
-          </a:p>
-        </p:txBody>
-      </p:sp>
-      <p:sp>
-        <p:nvSpPr>
-          <p:cNvPr id="14" name="Text 12"/>
-          <p:cNvSpPr txBox="1"/>
-          <p:nvPr/>
-        </p:nvSpPr>
-        <p:spPr>
-          <a:xfrm>
-            <a:off x="1463040" y="4050792"/>
-            <a:ext cx="5943600" cy="411480"/>
-          </a:xfrm>
-          <a:prstGeom prst="rect">
-            <a:avLst/>
-          </a:prstGeom>
-          <a:noFill/>
-          <a:ln/>
-        </p:spPr>
-        <p:txBody>
-          <a:bodyPr wrap="square" lIns="0" tIns="0" rIns="0" bIns="0" rtlCol="0" anchor="t"/>
-          <a:lstStyle/>
-          <a:p>
-            <a:pPr marL="0" indent="0" algn="l">
-              <a:buNone/>
-            </a:pPr>
-            <a:r>
-              <a:rPr lang="en-US" sz="2000" b="1" dirty="0">
-                <a:solidFill>
-                  <a:srgbClr val="FFFFFF"/>
-                </a:solidFill>
-                <a:latin typeface="Arial" pitchFamily="34" charset="0"/>
-                <a:ea typeface="Arial" pitchFamily="34" charset="-122"/>
-                <a:cs typeface="Arial" pitchFamily="34" charset="-120"/>
-              </a:rPr>
-              <a:t>Rotação de secret</a:t>
-            </a:r>
-            <a:endParaRPr lang="en-US" sz="2000" dirty="0"/>
-          </a:p>
-        </p:txBody>
-      </p:sp>
-      <p:sp>
-        <p:nvSpPr>
-          <p:cNvPr id="15" name="Text 13"/>
-          <p:cNvSpPr txBox="1"/>
-          <p:nvPr/>
-        </p:nvSpPr>
-        <p:spPr>
-          <a:xfrm>
-            <a:off x="1463040" y="4453128"/>
-            <a:ext cx="6217920" cy="457200"/>
-          </a:xfrm>
-          <a:prstGeom prst="rect">
-            <a:avLst/>
-          </a:prstGeom>
-          <a:noFill/>
-          <a:ln/>
-        </p:spPr>
-        <p:txBody>
-          <a:bodyPr wrap="square" lIns="0" tIns="0" rIns="0" bIns="0" rtlCol="0" anchor="t"/>
-          <a:lstStyle/>
-          <a:p>
-            <a:pPr marL="0" indent="0" algn="l">
-              <a:buNone/>
-            </a:pPr>
-            <a:r>
-              <a:rPr lang="en-US" sz="1400" dirty="0">
-                <a:solidFill>
-                  <a:srgbClr val="C9D1E0"/>
-                </a:solidFill>
-                <a:latin typeface="Arial" pitchFamily="34" charset="0"/>
-                <a:ea typeface="Arial" pitchFamily="34" charset="-122"/>
-                <a:cs typeface="Arial" pitchFamily="34" charset="-120"/>
-              </a:rPr>
-              <a:t>TTL no cache de pools para pegar senha rotacionada sem redeploy.</a:t>
-            </a:r>
-            <a:endParaRPr lang="en-US" sz="1400" dirty="0"/>
-          </a:p>
-        </p:txBody>
-      </p:sp>
-      <p:sp>
-        <p:nvSpPr>
-          <p:cNvPr id="16" name="Shape 14"/>
-          <p:cNvSpPr/>
-          <p:nvPr/>
-        </p:nvSpPr>
-        <p:spPr>
-          <a:xfrm>
-            <a:off x="8229600" y="1691640"/>
-            <a:ext cx="3429000" cy="3017520"/>
-          </a:xfrm>
-          <a:prstGeom prst="roundRect">
-            <a:avLst>
-              <a:gd name="adj" fmla="val 3636"/>
-            </a:avLst>
-          </a:prstGeom>
-          <a:solidFill>
-            <a:srgbClr val="1F2738"/>
-          </a:solidFill>
-          <a:ln/>
-        </p:spPr>
-        <p:txBody>
-          <a:bodyPr/>
-          <a:lstStyle/>
-          <a:p>
-            <a:endParaRPr lang="pt-BR"/>
-          </a:p>
-        </p:txBody>
-      </p:sp>
-      <p:sp>
-        <p:nvSpPr>
-          <p:cNvPr id="17" name="Text 15"/>
-          <p:cNvSpPr txBox="1"/>
-          <p:nvPr/>
-        </p:nvSpPr>
-        <p:spPr>
-          <a:xfrm>
-            <a:off x="8229600" y="2011680"/>
-            <a:ext cx="3429000" cy="731520"/>
-          </a:xfrm>
-          <a:prstGeom prst="rect">
-            <a:avLst/>
-          </a:prstGeom>
-          <a:noFill/>
-          <a:ln/>
-        </p:spPr>
-        <p:txBody>
-          <a:bodyPr wrap="square" lIns="0" tIns="0" rIns="0" bIns="0" rtlCol="0" anchor="t"/>
-          <a:lstStyle/>
-          <a:p>
-            <a:pPr marL="0" indent="0" algn="ctr">
-              <a:buNone/>
-            </a:pPr>
-            <a:r>
-              <a:rPr lang="en-US" sz="3200" b="1" dirty="0">
-                <a:solidFill>
-                  <a:srgbClr val="F59E0B"/>
-                </a:solidFill>
-                <a:latin typeface="Arial" pitchFamily="34" charset="0"/>
-                <a:ea typeface="Arial" pitchFamily="34" charset="-122"/>
-                <a:cs typeface="Arial" pitchFamily="34" charset="-120"/>
-              </a:rPr>
-              <a:t>Perguntas?</a:t>
-            </a:r>
-            <a:endParaRPr lang="en-US" sz="3200" dirty="0"/>
-          </a:p>
-        </p:txBody>
-      </p:sp>
-      <p:sp>
-        <p:nvSpPr>
-          <p:cNvPr id="18" name="Text 16"/>
-          <p:cNvSpPr txBox="1"/>
-          <p:nvPr/>
-        </p:nvSpPr>
-        <p:spPr>
-          <a:xfrm>
-            <a:off x="8458200" y="2834640"/>
-            <a:ext cx="2971800" cy="1645920"/>
-          </a:xfrm>
-          <a:prstGeom prst="rect">
-            <a:avLst/>
-          </a:prstGeom>
-          <a:noFill/>
-          <a:ln/>
-        </p:spPr>
-        <p:txBody>
-          <a:bodyPr wrap="square" lIns="0" tIns="0" rIns="0" bIns="0" rtlCol="0" anchor="t"/>
-          <a:lstStyle/>
-          <a:p>
-            <a:pPr marL="0" indent="0" algn="ctr">
-              <a:buNone/>
-            </a:pPr>
-            <a:r>
-              <a:rPr lang="en-US" sz="1300" dirty="0">
-                <a:solidFill>
-                  <a:srgbClr val="C9D1E0"/>
-                </a:solidFill>
-                <a:latin typeface="Arial" pitchFamily="34" charset="0"/>
-                <a:ea typeface="Arial" pitchFamily="34" charset="-122"/>
-                <a:cs typeface="Arial" pitchFamily="34" charset="-120"/>
-              </a:rPr>
-              <a:t>Código da demo:</a:t>
-            </a:r>
-            <a:endParaRPr lang="en-US" sz="1300" dirty="0"/>
-          </a:p>
-          <a:p>
-            <a:pPr marL="0" indent="0" algn="ctr">
-              <a:buNone/>
-            </a:pPr>
-            <a:r>
-              <a:rPr lang="en-US" sz="1300" dirty="0">
-                <a:solidFill>
-                  <a:srgbClr val="C9D1E0"/>
-                </a:solidFill>
-                <a:latin typeface="Arial" pitchFamily="34" charset="0"/>
-                <a:ea typeface="Arial" pitchFamily="34" charset="-122"/>
-                <a:cs typeface="Arial" pitchFamily="34" charset="-120"/>
-              </a:rPr>
-              <a:t>RH-Benficios/lambda-multitenant</a:t>
-            </a:r>
-            <a:endParaRPr lang="en-US" sz="1300" dirty="0"/>
-          </a:p>
-          <a:p>
-            <a:pPr marL="0" indent="0" algn="ctr">
-              <a:buNone/>
-            </a:pPr>
-            <a:endParaRPr lang="en-US" sz="1300" dirty="0"/>
-          </a:p>
-          <a:p>
-            <a:pPr marL="0" indent="0" algn="ctr">
-              <a:buNone/>
-            </a:pPr>
-            <a:r>
-              <a:rPr lang="en-US" sz="1300" dirty="0">
-                <a:solidFill>
-                  <a:srgbClr val="C9D1E0"/>
-                </a:solidFill>
-                <a:latin typeface="Arial" pitchFamily="34" charset="0"/>
-                <a:ea typeface="Arial" pitchFamily="34" charset="-122"/>
-                <a:cs typeface="Arial" pitchFamily="34" charset="-120"/>
-              </a:rPr>
-              <a:t>README.md · demo.ps1</a:t>
-            </a:r>
-            <a:endParaRPr lang="en-US" sz="1300" dirty="0"/>
           </a:p>
         </p:txBody>
       </p:sp>

</xml_diff>

<commit_message>
docs(apresentacao): slide com o modelo do secret de cada tenant (LocalStack)
Novo 5o slide "Um secret por tenant": trecho do init-secrets.sh com o JSON
do secret, relacao --name = X-Secret-Id, LocalStack via docker-compose e
AWS_ENDPOINT_URL (mesmo codigo local e na AWS). Inclui notas do apresentador.

Co-Authored-By: Claude Opus 5.5 <noreply@anthropic.com>
</commit_message>
<xml_diff>
--- a/docs/lambda-multitenant-workshop-apresentação-final.pptx
+++ b/docs/lambda-multitenant-workshop-apresentação-final.pptx
@@ -12,6 +12,7 @@
     <p:sldId id="257" r:id="rId3"/>
     <p:sldId id="258" r:id="rId4"/>
     <p:sldId id="259" r:id="rId5"/>
+    <p:sldId id="262" r:id="rId13"/>
     <p:sldId id="260" r:id="rId6"/>
     <p:sldId id="261" r:id="rId7"/>
   </p:sldIdLst>
@@ -746,6 +747,93 @@
             <a:fld id="{F7021451-1387-4CA6-816F-3879F97B5CBC}" type="slidenum">
               <a:rPr lang="en-US"/>
               <a:t>6</a:t>
+            </a:fld>
+            <a:endParaRPr lang="en-US"/>
+          </a:p>
+        </p:txBody>
+      </p:sp>
+    </p:spTree>
+    <p:extLst>
+      <p:ext uri="{BB962C8B-B14F-4D97-AF65-F5344CB8AC3E}">
+        <p14:creationId xmlns:p14="http://schemas.microsoft.com/office/powerpoint/2010/main" val="1024086991"/>
+      </p:ext>
+    </p:extLst>
+  </p:cSld>
+  <p:clrMapOvr>
+    <a:masterClrMapping/>
+  </p:clrMapOvr>
+</p:notes>
+</file>
+
+<file path=ppt/notesSlides/notesSlide7.xml><?xml version="1.0" encoding="utf-8"?>
+<p:notes xmlns:a="http://schemas.openxmlformats.org/drawingml/2006/main" xmlns:r="http://schemas.openxmlformats.org/officeDocument/2006/relationships" xmlns:p="http://schemas.openxmlformats.org/presentationml/2006/main">
+  <p:cSld>
+    <p:spTree>
+      <p:nvGrpSpPr>
+        <p:cNvPr id="1" name=""/>
+        <p:cNvGrpSpPr/>
+        <p:nvPr/>
+      </p:nvGrpSpPr>
+      <p:grpSpPr>
+        <a:xfrm>
+          <a:off x="0" y="0"/>
+          <a:ext cx="0" cy="0"/>
+          <a:chOff x="0" y="0"/>
+          <a:chExt cx="0" cy="0"/>
+        </a:xfrm>
+      </p:grpSpPr>
+      <p:sp>
+        <p:nvSpPr>
+          <p:cNvPr id="2" name="Slide Image Placeholder 1"/>
+          <p:cNvSpPr>
+            <a:spLocks noGrp="1" noRot="1" noChangeAspect="1"/>
+          </p:cNvSpPr>
+          <p:nvPr>
+            <p:ph type="sldImg"/>
+          </p:nvPr>
+        </p:nvSpPr>
+        <p:spPr/>
+      </p:sp>
+      <p:sp>
+        <p:nvSpPr>
+          <p:cNvPr id="3" name="Notes Placeholder 2"/>
+          <p:cNvSpPr>
+            <a:spLocks noGrp="1"/>
+          </p:cNvSpPr>
+          <p:nvPr>
+            <p:ph type="body" idx="1"/>
+          </p:nvPr>
+        </p:nvSpPr>
+        <p:spPr/>
+        <p:txBody>
+          <a:bodyPr/>
+          <a:lstStyle/>
+          <a:p>
+            <a:r>
+              <a:rPr lang="pt-BR" dirty="0"/>
+              <a:t>Mostrar docker/localstack/init-secrets.sh. Cada tenant é só um JSON no Secrets Manager com host, porta, banco, usuário e senha — o mesmo formato dos secrets de RDS. O nome do secret é o que o cliente manda no X-Secret-Id. Localmente o LocalStack faz o papel da AWS; em produção o código é o mesmo, só não existe a variável AWS_ENDPOINT_URL. Cliente novo = criar um secret novo, sem deploy.</a:t>
+            </a:r>
+          </a:p>
+        </p:txBody>
+      </p:sp>
+      <p:sp>
+        <p:nvSpPr>
+          <p:cNvPr id="4" name="Slide Number Placeholder 3"/>
+          <p:cNvSpPr>
+            <a:spLocks noGrp="1"/>
+          </p:cNvSpPr>
+          <p:nvPr>
+            <p:ph type="sldNum" sz="quarter" idx="10"/>
+          </p:nvPr>
+        </p:nvSpPr>
+        <p:spPr/>
+        <p:txBody>
+          <a:bodyPr/>
+          <a:lstStyle/>
+          <a:p>
+            <a:fld id="{F7021451-1387-4CA6-816F-3879F97B5CBC}" type="slidenum">
+              <a:rPr lang="en-US"/>
+              <a:t>4</a:t>
             </a:fld>
             <a:endParaRPr lang="en-US"/>
           </a:p>
@@ -7520,6 +7608,787 @@
               <a:t>Depois disso, só cache.</a:t>
             </a:r>
             <a:endParaRPr lang="en-US" sz="1400" dirty="0"/>
+          </a:p>
+        </p:txBody>
+      </p:sp>
+    </p:spTree>
+  </p:cSld>
+  <p:clrMapOvr>
+    <a:masterClrMapping/>
+  </p:clrMapOvr>
+</p:sld>
+</file>
+
+<file path=ppt/slides/slide7.xml><?xml version="1.0" encoding="utf-8"?>
+<p:sld xmlns:a="http://schemas.openxmlformats.org/drawingml/2006/main" xmlns:r="http://schemas.openxmlformats.org/officeDocument/2006/relationships" xmlns:p="http://schemas.openxmlformats.org/presentationml/2006/main">
+  <p:cSld name="Slide 4">
+    <p:bg>
+      <p:bgPr>
+        <a:solidFill>
+          <a:srgbClr val="141A26"/>
+        </a:solidFill>
+        <a:effectLst/>
+      </p:bgPr>
+    </p:bg>
+    <p:spTree>
+      <p:nvGrpSpPr>
+        <p:cNvPr id="1" name=""/>
+        <p:cNvGrpSpPr/>
+        <p:nvPr/>
+      </p:nvGrpSpPr>
+      <p:grpSpPr>
+        <a:xfrm>
+          <a:off x="0" y="0"/>
+          <a:ext cx="0" cy="0"/>
+          <a:chOff x="0" y="0"/>
+          <a:chExt cx="0" cy="0"/>
+        </a:xfrm>
+      </p:grpSpPr>
+      <p:sp>
+        <p:nvSpPr>
+          <p:cNvPr id="2" name="Text 0"/>
+          <p:cNvSpPr txBox="1"/>
+          <p:nvPr/>
+        </p:nvSpPr>
+        <p:spPr>
+          <a:xfrm>
+            <a:off x="548640" y="137160"/>
+            <a:ext cx="7315200" cy="320040"/>
+          </a:xfrm>
+          <a:prstGeom prst="rect">
+            <a:avLst/>
+          </a:prstGeom>
+          <a:noFill/>
+          <a:ln/>
+        </p:spPr>
+        <p:txBody>
+          <a:bodyPr wrap="square" lIns="0" tIns="0" rIns="0" bIns="0" rtlCol="0" anchor="ctr"/>
+          <a:lstStyle/>
+          <a:p>
+            <a:pPr marL="0" indent="0">
+              <a:buNone/>
+            </a:pPr>
+            <a:r>
+              <a:rPr lang="en-US" sz="1200" b="1" kern="0" spc="200" dirty="0">
+                <a:solidFill>
+                  <a:srgbClr val="F59E0B"/>
+                </a:solidFill>
+                <a:latin typeface="Arial" pitchFamily="34" charset="0"/>
+                <a:ea typeface="Arial" pitchFamily="34" charset="-122"/>
+                <a:cs typeface="Arial" pitchFamily="34" charset="-120"/>
+              </a:rPr>
+              <a:t>02 · O SECRET DE CADA TENANT</a:t>
+            </a:r>
+            <a:endParaRPr lang="en-US" sz="1200" dirty="0"/>
+          </a:p>
+        </p:txBody>
+      </p:sp>
+      <p:sp>
+        <p:nvSpPr>
+          <p:cNvPr id="3" name="Text 1"/>
+          <p:cNvSpPr txBox="1"/>
+          <p:nvPr/>
+        </p:nvSpPr>
+        <p:spPr>
+          <a:xfrm>
+            <a:off x="548640" y="411480"/>
+            <a:ext cx="11064240" cy="822960"/>
+          </a:xfrm>
+          <a:prstGeom prst="rect">
+            <a:avLst/>
+          </a:prstGeom>
+          <a:noFill/>
+          <a:ln/>
+        </p:spPr>
+        <p:txBody>
+          <a:bodyPr wrap="square" lIns="0" tIns="0" rIns="0" bIns="0" rtlCol="0" anchor="ctr"/>
+          <a:lstStyle/>
+          <a:p>
+            <a:pPr marL="0" indent="0">
+              <a:buNone/>
+            </a:pPr>
+            <a:r>
+              <a:rPr lang="en-US" sz="3400" b="1" dirty="0">
+                <a:solidFill>
+                  <a:srgbClr val="FFFFFF"/>
+                </a:solidFill>
+                <a:latin typeface="Arial" pitchFamily="34" charset="0"/>
+                <a:ea typeface="Arial" pitchFamily="34" charset="-122"/>
+                <a:cs typeface="Arial" pitchFamily="34" charset="-120"/>
+              </a:rPr>
+              <a:t>Um secret por tenant</a:t>
+            </a:r>
+            <a:endParaRPr lang="en-US" sz="3400" dirty="0"/>
+          </a:p>
+        </p:txBody>
+      </p:sp>
+      <p:sp>
+        <p:nvSpPr>
+          <p:cNvPr id="4" name="Shape 2"/>
+          <p:cNvSpPr/>
+          <p:nvPr/>
+        </p:nvSpPr>
+        <p:spPr>
+          <a:xfrm>
+            <a:off x="548640" y="1508760"/>
+            <a:ext cx="6949440" cy="4343400"/>
+          </a:xfrm>
+          <a:prstGeom prst="roundRect">
+            <a:avLst>
+              <a:gd name="adj" fmla="val 2526"/>
+            </a:avLst>
+          </a:prstGeom>
+          <a:solidFill>
+            <a:srgbClr val="1F2738"/>
+          </a:solidFill>
+          <a:ln/>
+        </p:spPr>
+        <p:txBody>
+          <a:bodyPr/>
+          <a:lstStyle/>
+          <a:p>
+            <a:endParaRPr lang="pt-BR"/>
+          </a:p>
+        </p:txBody>
+      </p:sp>
+      <p:sp>
+        <p:nvSpPr>
+          <p:cNvPr id="5" name="Text 3"/>
+          <p:cNvSpPr txBox="1"/>
+          <p:nvPr/>
+        </p:nvSpPr>
+        <p:spPr>
+          <a:xfrm>
+            <a:off x="822960" y="1828800"/>
+            <a:ext cx="6492240" cy="3840480"/>
+          </a:xfrm>
+          <a:prstGeom prst="rect">
+            <a:avLst/>
+          </a:prstGeom>
+          <a:noFill/>
+          <a:ln/>
+        </p:spPr>
+        <p:txBody>
+          <a:bodyPr wrap="square" lIns="0" tIns="0" rIns="0" bIns="0" rtlCol="0" anchor="t"/>
+          <a:lstStyle/>
+          <a:p>
+            <a:pPr marL="0" indent="0">
+              <a:buNone/>
+            </a:pPr>
+            <a:r>
+              <a:rPr lang="en-US" sz="1500" dirty="0">
+                <a:solidFill>
+                  <a:srgbClr val="8A94A8"/>
+                </a:solidFill>
+                <a:latin typeface="Courier New" pitchFamily="34" charset="0"/>
+                <a:ea typeface="Courier New" pitchFamily="34" charset="-122"/>
+                <a:cs typeface="Courier New" pitchFamily="34" charset="-120"/>
+              </a:rPr>
+              <a:t># docker/localstack/init-secrets.sh</a:t>
+            </a:r>
+            <a:endParaRPr lang="en-US" sz="1500" dirty="0"/>
+          </a:p>
+          <a:p>
+            <a:pPr marL="0" indent="0">
+              <a:buNone/>
+            </a:pPr>
+            <a:r>
+              <a:rPr lang="en-US" sz="1500" dirty="0">
+                <a:solidFill>
+                  <a:srgbClr val="E6EAF2"/>
+                </a:solidFill>
+                <a:latin typeface="Courier New" pitchFamily="34" charset="0"/>
+                <a:ea typeface="Courier New" pitchFamily="34" charset="-122"/>
+                <a:cs typeface="Courier New" pitchFamily="34" charset="-120"/>
+              </a:rPr>
+              <a:t>awslocal secretsmanager create-secret \</a:t>
+            </a:r>
+            <a:endParaRPr lang="en-US" sz="1500" dirty="0"/>
+          </a:p>
+          <a:p>
+            <a:pPr marL="0" indent="0">
+              <a:buNone/>
+            </a:pPr>
+            <a:r>
+              <a:rPr lang="en-US" sz="1500" dirty="0">
+                <a:solidFill>
+                  <a:srgbClr val="F59E0B"/>
+                </a:solidFill>
+                <a:latin typeface="Courier New" pitchFamily="34" charset="0"/>
+                <a:ea typeface="Courier New" pitchFamily="34" charset="-122"/>
+                <a:cs typeface="Courier New" pitchFamily="34" charset="-120"/>
+              </a:rPr>
+              <a:t>  --name workshop/tenant-a \</a:t>
+            </a:r>
+            <a:endParaRPr lang="en-US" sz="1500" dirty="0"/>
+          </a:p>
+          <a:p>
+            <a:pPr marL="0" indent="0">
+              <a:buNone/>
+            </a:pPr>
+            <a:r>
+              <a:rPr lang="en-US" sz="1500" dirty="0">
+                <a:solidFill>
+                  <a:srgbClr val="E6EAF2"/>
+                </a:solidFill>
+                <a:latin typeface="Courier New" pitchFamily="34" charset="0"/>
+                <a:ea typeface="Courier New" pitchFamily="34" charset="-122"/>
+                <a:cs typeface="Courier New" pitchFamily="34" charset="-120"/>
+              </a:rPr>
+              <a:t>  --secret-string '{</a:t>
+            </a:r>
+            <a:endParaRPr lang="en-US" sz="1500" dirty="0"/>
+          </a:p>
+          <a:p>
+            <a:pPr marL="0" indent="0">
+              <a:buNone/>
+            </a:pPr>
+            <a:r>
+              <a:rPr lang="en-US" sz="1500" dirty="0">
+                <a:solidFill>
+                  <a:srgbClr val="E6EAF2"/>
+                </a:solidFill>
+                <a:latin typeface="Courier New" pitchFamily="34" charset="0"/>
+                <a:ea typeface="Courier New" pitchFamily="34" charset="-122"/>
+                <a:cs typeface="Courier New" pitchFamily="34" charset="-120"/>
+              </a:rPr>
+              <a:t>      "host":     "localhost",</a:t>
+            </a:r>
+            <a:endParaRPr lang="en-US" sz="1500" dirty="0"/>
+          </a:p>
+          <a:p>
+            <a:pPr marL="0" indent="0">
+              <a:buNone/>
+            </a:pPr>
+            <a:r>
+              <a:rPr lang="en-US" sz="1500" dirty="0">
+                <a:solidFill>
+                  <a:srgbClr val="E6EAF2"/>
+                </a:solidFill>
+                <a:latin typeface="Courier New" pitchFamily="34" charset="0"/>
+                <a:ea typeface="Courier New" pitchFamily="34" charset="-122"/>
+                <a:cs typeface="Courier New" pitchFamily="34" charset="-120"/>
+              </a:rPr>
+              <a:t>      "port":     5433,</a:t>
+            </a:r>
+            <a:endParaRPr lang="en-US" sz="1500" dirty="0"/>
+          </a:p>
+          <a:p>
+            <a:pPr marL="0" indent="0">
+              <a:buNone/>
+            </a:pPr>
+            <a:r>
+              <a:rPr lang="en-US" sz="1500" dirty="0">
+                <a:solidFill>
+                  <a:srgbClr val="E6EAF2"/>
+                </a:solidFill>
+                <a:latin typeface="Courier New" pitchFamily="34" charset="0"/>
+                <a:ea typeface="Courier New" pitchFamily="34" charset="-122"/>
+                <a:cs typeface="Courier New" pitchFamily="34" charset="-120"/>
+              </a:rPr>
+              <a:t>      "dbname":   "tenant_a",</a:t>
+            </a:r>
+            <a:endParaRPr lang="en-US" sz="1500" dirty="0"/>
+          </a:p>
+          <a:p>
+            <a:pPr marL="0" indent="0">
+              <a:buNone/>
+            </a:pPr>
+            <a:r>
+              <a:rPr lang="en-US" sz="1500" dirty="0">
+                <a:solidFill>
+                  <a:srgbClr val="E6EAF2"/>
+                </a:solidFill>
+                <a:latin typeface="Courier New" pitchFamily="34" charset="0"/>
+                <a:ea typeface="Courier New" pitchFamily="34" charset="-122"/>
+                <a:cs typeface="Courier New" pitchFamily="34" charset="-120"/>
+              </a:rPr>
+              <a:t>      "username": "tenant_a_user",</a:t>
+            </a:r>
+            <a:endParaRPr lang="en-US" sz="1500" dirty="0"/>
+          </a:p>
+          <a:p>
+            <a:pPr marL="0" indent="0">
+              <a:buNone/>
+            </a:pPr>
+            <a:r>
+              <a:rPr lang="en-US" sz="1500" dirty="0">
+                <a:solidFill>
+                  <a:srgbClr val="E6EAF2"/>
+                </a:solidFill>
+                <a:latin typeface="Courier New" pitchFamily="34" charset="0"/>
+                <a:ea typeface="Courier New" pitchFamily="34" charset="-122"/>
+                <a:cs typeface="Courier New" pitchFamily="34" charset="-120"/>
+              </a:rPr>
+              <a:t>      "password": "senha_a"</a:t>
+            </a:r>
+            <a:endParaRPr lang="en-US" sz="1500" dirty="0"/>
+          </a:p>
+          <a:p>
+            <a:pPr marL="0" indent="0">
+              <a:buNone/>
+            </a:pPr>
+            <a:r>
+              <a:rPr lang="en-US" sz="1500" dirty="0">
+                <a:solidFill>
+                  <a:srgbClr val="E6EAF2"/>
+                </a:solidFill>
+                <a:latin typeface="Courier New" pitchFamily="34" charset="0"/>
+                <a:ea typeface="Courier New" pitchFamily="34" charset="-122"/>
+                <a:cs typeface="Courier New" pitchFamily="34" charset="-120"/>
+              </a:rPr>
+              <a:t>  }'</a:t>
+            </a:r>
+            <a:endParaRPr lang="en-US" sz="1500" dirty="0"/>
+          </a:p>
+          <a:p>
+            <a:pPr marL="0" indent="0">
+              <a:buNone/>
+            </a:pPr>
+            <a:r>
+              <a:rPr lang="en-US" sz="1500" dirty="0">
+                <a:solidFill>
+                  <a:srgbClr val="E6EAF2"/>
+                </a:solidFill>
+                <a:latin typeface="Courier New" pitchFamily="34" charset="0"/>
+                <a:ea typeface="Courier New" pitchFamily="34" charset="-122"/>
+                <a:cs typeface="Courier New" pitchFamily="34" charset="-120"/>
+              </a:rPr>
+              <a:t> </a:t>
+            </a:r>
+            <a:endParaRPr lang="en-US" sz="1500" dirty="0"/>
+          </a:p>
+        </p:txBody>
+      </p:sp>
+      <p:sp>
+        <p:nvSpPr>
+          <p:cNvPr id="6" name="Shape 4"/>
+          <p:cNvSpPr/>
+          <p:nvPr/>
+        </p:nvSpPr>
+        <p:spPr>
+          <a:xfrm>
+            <a:off x="7955280" y="1645920"/>
+            <a:ext cx="502920" cy="502920"/>
+          </a:xfrm>
+          <a:prstGeom prst="ellipse">
+            <a:avLst/>
+          </a:prstGeom>
+          <a:solidFill>
+            <a:srgbClr val="F59E0B"/>
+          </a:solidFill>
+          <a:ln/>
+        </p:spPr>
+        <p:txBody>
+          <a:bodyPr/>
+          <a:lstStyle/>
+          <a:p>
+            <a:endParaRPr lang="pt-BR"/>
+          </a:p>
+        </p:txBody>
+      </p:sp>
+      <p:sp>
+        <p:nvSpPr>
+          <p:cNvPr id="7" name="Text 5"/>
+          <p:cNvSpPr txBox="1"/>
+          <p:nvPr/>
+        </p:nvSpPr>
+        <p:spPr>
+          <a:xfrm>
+            <a:off x="7955280" y="1645920"/>
+            <a:ext cx="502920" cy="502920"/>
+          </a:xfrm>
+          <a:prstGeom prst="rect">
+            <a:avLst/>
+          </a:prstGeom>
+          <a:noFill/>
+          <a:ln/>
+        </p:spPr>
+        <p:txBody>
+          <a:bodyPr wrap="square" lIns="0" tIns="0" rIns="0" bIns="0" rtlCol="0" anchor="ctr"/>
+          <a:lstStyle/>
+          <a:p>
+            <a:pPr marL="0" indent="0" algn="ctr">
+              <a:buNone/>
+            </a:pPr>
+            <a:r>
+              <a:rPr lang="en-US" sz="1600" b="1" dirty="0">
+                <a:solidFill>
+                  <a:srgbClr val="141A26"/>
+                </a:solidFill>
+                <a:latin typeface="Arial" pitchFamily="34" charset="0"/>
+                <a:ea typeface="Arial" pitchFamily="34" charset="-122"/>
+                <a:cs typeface="Arial" pitchFamily="34" charset="-120"/>
+              </a:rPr>
+              <a:t>1</a:t>
+            </a:r>
+            <a:endParaRPr lang="en-US" sz="1600" dirty="0"/>
+          </a:p>
+        </p:txBody>
+      </p:sp>
+      <p:sp>
+        <p:nvSpPr>
+          <p:cNvPr id="8" name="Text 6"/>
+          <p:cNvSpPr txBox="1"/>
+          <p:nvPr/>
+        </p:nvSpPr>
+        <p:spPr>
+          <a:xfrm>
+            <a:off x="8686800" y="1627632"/>
+            <a:ext cx="3017520" cy="411480"/>
+          </a:xfrm>
+          <a:prstGeom prst="rect">
+            <a:avLst/>
+          </a:prstGeom>
+          <a:noFill/>
+          <a:ln/>
+        </p:spPr>
+        <p:txBody>
+          <a:bodyPr wrap="square" lIns="0" tIns="0" rIns="0" bIns="0" rtlCol="0" anchor="t"/>
+          <a:lstStyle/>
+          <a:p>
+            <a:pPr marL="0" indent="0" algn="l">
+              <a:buNone/>
+            </a:pPr>
+            <a:r>
+              <a:rPr lang="en-US" sz="1700" b="1" dirty="0">
+                <a:solidFill>
+                  <a:srgbClr val="FFFFFF"/>
+                </a:solidFill>
+                <a:latin typeface="Arial" pitchFamily="34" charset="0"/>
+                <a:ea typeface="Arial" pitchFamily="34" charset="-122"/>
+                <a:cs typeface="Arial" pitchFamily="34" charset="-120"/>
+              </a:rPr>
+              <a:t>Nome = X-Secret-Id</a:t>
+            </a:r>
+            <a:endParaRPr lang="en-US" sz="1700" dirty="0"/>
+          </a:p>
+        </p:txBody>
+      </p:sp>
+      <p:sp>
+        <p:nvSpPr>
+          <p:cNvPr id="9" name="Text 7"/>
+          <p:cNvSpPr txBox="1"/>
+          <p:nvPr/>
+        </p:nvSpPr>
+        <p:spPr>
+          <a:xfrm>
+            <a:off x="8686800" y="2057400"/>
+            <a:ext cx="3017520" cy="822960"/>
+          </a:xfrm>
+          <a:prstGeom prst="rect">
+            <a:avLst/>
+          </a:prstGeom>
+          <a:noFill/>
+          <a:ln/>
+        </p:spPr>
+        <p:txBody>
+          <a:bodyPr wrap="square" lIns="0" tIns="0" rIns="0" bIns="0" rtlCol="0" anchor="t"/>
+          <a:lstStyle/>
+          <a:p>
+            <a:pPr marL="0" indent="0" algn="l">
+              <a:buNone/>
+            </a:pPr>
+            <a:r>
+              <a:rPr lang="en-US" sz="1300" dirty="0">
+                <a:solidFill>
+                  <a:srgbClr val="C9D1E0"/>
+                </a:solidFill>
+                <a:latin typeface="Arial" pitchFamily="34" charset="0"/>
+                <a:ea typeface="Arial" pitchFamily="34" charset="-122"/>
+                <a:cs typeface="Arial" pitchFamily="34" charset="-120"/>
+              </a:rPr>
+              <a:t>O --name do secret é exatamente o valor enviado no header.</a:t>
+            </a:r>
+            <a:endParaRPr lang="en-US" sz="1300" dirty="0"/>
+          </a:p>
+        </p:txBody>
+      </p:sp>
+      <p:sp>
+        <p:nvSpPr>
+          <p:cNvPr id="10" name="Shape 8"/>
+          <p:cNvSpPr/>
+          <p:nvPr/>
+        </p:nvSpPr>
+        <p:spPr>
+          <a:xfrm>
+            <a:off x="7955280" y="3108960"/>
+            <a:ext cx="502920" cy="502920"/>
+          </a:xfrm>
+          <a:prstGeom prst="ellipse">
+            <a:avLst/>
+          </a:prstGeom>
+          <a:solidFill>
+            <a:srgbClr val="F59E0B"/>
+          </a:solidFill>
+          <a:ln/>
+        </p:spPr>
+        <p:txBody>
+          <a:bodyPr/>
+          <a:lstStyle/>
+          <a:p>
+            <a:endParaRPr lang="pt-BR"/>
+          </a:p>
+        </p:txBody>
+      </p:sp>
+      <p:sp>
+        <p:nvSpPr>
+          <p:cNvPr id="11" name="Text 9"/>
+          <p:cNvSpPr txBox="1"/>
+          <p:nvPr/>
+        </p:nvSpPr>
+        <p:spPr>
+          <a:xfrm>
+            <a:off x="7955280" y="3108960"/>
+            <a:ext cx="502920" cy="502920"/>
+          </a:xfrm>
+          <a:prstGeom prst="rect">
+            <a:avLst/>
+          </a:prstGeom>
+          <a:noFill/>
+          <a:ln/>
+        </p:spPr>
+        <p:txBody>
+          <a:bodyPr wrap="square" lIns="0" tIns="0" rIns="0" bIns="0" rtlCol="0" anchor="ctr"/>
+          <a:lstStyle/>
+          <a:p>
+            <a:pPr marL="0" indent="0" algn="ctr">
+              <a:buNone/>
+            </a:pPr>
+            <a:r>
+              <a:rPr lang="en-US" sz="1600" b="1" dirty="0">
+                <a:solidFill>
+                  <a:srgbClr val="141A26"/>
+                </a:solidFill>
+                <a:latin typeface="Arial" pitchFamily="34" charset="0"/>
+                <a:ea typeface="Arial" pitchFamily="34" charset="-122"/>
+                <a:cs typeface="Arial" pitchFamily="34" charset="-120"/>
+              </a:rPr>
+              <a:t>2</a:t>
+            </a:r>
+            <a:endParaRPr lang="en-US" sz="1600" dirty="0"/>
+          </a:p>
+        </p:txBody>
+      </p:sp>
+      <p:sp>
+        <p:nvSpPr>
+          <p:cNvPr id="12" name="Text 10"/>
+          <p:cNvSpPr txBox="1"/>
+          <p:nvPr/>
+        </p:nvSpPr>
+        <p:spPr>
+          <a:xfrm>
+            <a:off x="8686800" y="3090672"/>
+            <a:ext cx="3017520" cy="411480"/>
+          </a:xfrm>
+          <a:prstGeom prst="rect">
+            <a:avLst/>
+          </a:prstGeom>
+          <a:noFill/>
+          <a:ln/>
+        </p:spPr>
+        <p:txBody>
+          <a:bodyPr wrap="square" lIns="0" tIns="0" rIns="0" bIns="0" rtlCol="0" anchor="t"/>
+          <a:lstStyle/>
+          <a:p>
+            <a:pPr marL="0" indent="0" algn="l">
+              <a:buNone/>
+            </a:pPr>
+            <a:r>
+              <a:rPr lang="en-US" sz="1700" b="1" dirty="0">
+                <a:solidFill>
+                  <a:srgbClr val="FFFFFF"/>
+                </a:solidFill>
+                <a:latin typeface="Arial" pitchFamily="34" charset="0"/>
+                <a:ea typeface="Arial" pitchFamily="34" charset="-122"/>
+                <a:cs typeface="Arial" pitchFamily="34" charset="-120"/>
+              </a:rPr>
+              <a:t>LocalStack no Docker</a:t>
+            </a:r>
+            <a:endParaRPr lang="en-US" sz="1700" dirty="0"/>
+          </a:p>
+        </p:txBody>
+      </p:sp>
+      <p:sp>
+        <p:nvSpPr>
+          <p:cNvPr id="13" name="Text 11"/>
+          <p:cNvSpPr txBox="1"/>
+          <p:nvPr/>
+        </p:nvSpPr>
+        <p:spPr>
+          <a:xfrm>
+            <a:off x="8686800" y="3520440"/>
+            <a:ext cx="3017520" cy="822960"/>
+          </a:xfrm>
+          <a:prstGeom prst="rect">
+            <a:avLst/>
+          </a:prstGeom>
+          <a:noFill/>
+          <a:ln/>
+        </p:spPr>
+        <p:txBody>
+          <a:bodyPr wrap="square" lIns="0" tIns="0" rIns="0" bIns="0" rtlCol="0" anchor="t"/>
+          <a:lstStyle/>
+          <a:p>
+            <a:pPr marL="0" indent="0" algn="l">
+              <a:buNone/>
+            </a:pPr>
+            <a:r>
+              <a:rPr lang="en-US" sz="1300" dirty="0">
+                <a:solidFill>
+                  <a:srgbClr val="C9D1E0"/>
+                </a:solidFill>
+                <a:latin typeface="Arial" pitchFamily="34" charset="0"/>
+                <a:ea typeface="Arial" pitchFamily="34" charset="-122"/>
+                <a:cs typeface="Arial" pitchFamily="34" charset="-120"/>
+              </a:rPr>
+              <a:t>O docker-compose sobe o LocalStack e roda este script ao ficar pronto.</a:t>
+            </a:r>
+            <a:endParaRPr lang="en-US" sz="1300" dirty="0"/>
+          </a:p>
+        </p:txBody>
+      </p:sp>
+      <p:sp>
+        <p:nvSpPr>
+          <p:cNvPr id="14" name="Shape 12"/>
+          <p:cNvSpPr/>
+          <p:nvPr/>
+        </p:nvSpPr>
+        <p:spPr>
+          <a:xfrm>
+            <a:off x="7955280" y="4572000"/>
+            <a:ext cx="502920" cy="502920"/>
+          </a:xfrm>
+          <a:prstGeom prst="ellipse">
+            <a:avLst/>
+          </a:prstGeom>
+          <a:solidFill>
+            <a:srgbClr val="F59E0B"/>
+          </a:solidFill>
+          <a:ln/>
+        </p:spPr>
+        <p:txBody>
+          <a:bodyPr/>
+          <a:lstStyle/>
+          <a:p>
+            <a:endParaRPr lang="pt-BR"/>
+          </a:p>
+        </p:txBody>
+      </p:sp>
+      <p:sp>
+        <p:nvSpPr>
+          <p:cNvPr id="15" name="Text 13"/>
+          <p:cNvSpPr txBox="1"/>
+          <p:nvPr/>
+        </p:nvSpPr>
+        <p:spPr>
+          <a:xfrm>
+            <a:off x="7955280" y="4572000"/>
+            <a:ext cx="502920" cy="502920"/>
+          </a:xfrm>
+          <a:prstGeom prst="rect">
+            <a:avLst/>
+          </a:prstGeom>
+          <a:noFill/>
+          <a:ln/>
+        </p:spPr>
+        <p:txBody>
+          <a:bodyPr wrap="square" lIns="0" tIns="0" rIns="0" bIns="0" rtlCol="0" anchor="ctr"/>
+          <a:lstStyle/>
+          <a:p>
+            <a:pPr marL="0" indent="0" algn="ctr">
+              <a:buNone/>
+            </a:pPr>
+            <a:r>
+              <a:rPr lang="en-US" sz="1600" b="1" dirty="0">
+                <a:solidFill>
+                  <a:srgbClr val="141A26"/>
+                </a:solidFill>
+                <a:latin typeface="Arial" pitchFamily="34" charset="0"/>
+                <a:ea typeface="Arial" pitchFamily="34" charset="-122"/>
+                <a:cs typeface="Arial" pitchFamily="34" charset="-120"/>
+              </a:rPr>
+              <a:t>3</a:t>
+            </a:r>
+            <a:endParaRPr lang="en-US" sz="1600" dirty="0"/>
+          </a:p>
+        </p:txBody>
+      </p:sp>
+      <p:sp>
+        <p:nvSpPr>
+          <p:cNvPr id="16" name="Text 14"/>
+          <p:cNvSpPr txBox="1"/>
+          <p:nvPr/>
+        </p:nvSpPr>
+        <p:spPr>
+          <a:xfrm>
+            <a:off x="8686800" y="4553712"/>
+            <a:ext cx="3017520" cy="411480"/>
+          </a:xfrm>
+          <a:prstGeom prst="rect">
+            <a:avLst/>
+          </a:prstGeom>
+          <a:noFill/>
+          <a:ln/>
+        </p:spPr>
+        <p:txBody>
+          <a:bodyPr wrap="square" lIns="0" tIns="0" rIns="0" bIns="0" rtlCol="0" anchor="t"/>
+          <a:lstStyle/>
+          <a:p>
+            <a:pPr marL="0" indent="0" algn="l">
+              <a:buNone/>
+            </a:pPr>
+            <a:r>
+              <a:rPr lang="en-US" sz="1700" b="1" dirty="0">
+                <a:solidFill>
+                  <a:srgbClr val="FFFFFF"/>
+                </a:solidFill>
+                <a:latin typeface="Arial" pitchFamily="34" charset="0"/>
+                <a:ea typeface="Arial" pitchFamily="34" charset="-122"/>
+                <a:cs typeface="Arial" pitchFamily="34" charset="-120"/>
+              </a:rPr>
+              <a:t>Mesmo código na AWS</a:t>
+            </a:r>
+            <a:endParaRPr lang="en-US" sz="1700" dirty="0"/>
+          </a:p>
+        </p:txBody>
+      </p:sp>
+      <p:sp>
+        <p:nvSpPr>
+          <p:cNvPr id="17" name="Text 15"/>
+          <p:cNvSpPr txBox="1"/>
+          <p:nvPr/>
+        </p:nvSpPr>
+        <p:spPr>
+          <a:xfrm>
+            <a:off x="8686800" y="4983480"/>
+            <a:ext cx="3017520" cy="1143000"/>
+          </a:xfrm>
+          <a:prstGeom prst="rect">
+            <a:avLst/>
+          </a:prstGeom>
+          <a:noFill/>
+          <a:ln/>
+        </p:spPr>
+        <p:txBody>
+          <a:bodyPr wrap="square" lIns="0" tIns="0" rIns="0" bIns="0" rtlCol="0" anchor="t"/>
+          <a:lstStyle/>
+          <a:p>
+            <a:pPr marL="0" indent="0" algn="l">
+              <a:buNone/>
+            </a:pPr>
+            <a:r>
+              <a:rPr lang="en-US" sz="1300" dirty="0">
+                <a:solidFill>
+                  <a:srgbClr val="C9D1E0"/>
+                </a:solidFill>
+                <a:latin typeface="Arial" pitchFamily="34" charset="0"/>
+                <a:ea typeface="Arial" pitchFamily="34" charset="-122"/>
+                <a:cs typeface="Arial" pitchFamily="34" charset="-120"/>
+              </a:rPr>
+              <a:t>AWS_ENDPOINT_URL aponta o client para o LocalStack. Sem ela, vai para o Secrets Manager real.</a:t>
+            </a:r>
+            <a:endParaRPr lang="en-US" sz="1300" dirty="0"/>
           </a:p>
         </p:txBody>
       </p:sp>

</xml_diff>